<commit_message>
fix: address Phase 5 review
environment.yml lists the bioconda and gurobi channels of PyPSA-Earth's lock file and pins the new packages (dry-run solve passes). Report and deck carry the author's metadata and read every result number from results/*.csv or the register, with asserts where the text states a result. dispatch_by_carrier raises on carriers without a colour; price duration x axis uses snapshot weightings; system-cost figure notes that only differences matter; flexibility wording corrected; README layout updated.
</commit_message>
<xml_diff>
--- a/report/deck.pptx
+++ b/report/deck.pptx
@@ -929,7 +929,7 @@
           <a:lstStyle/>
           <a:p>
             <a:r>
-              <a:t>At the base gas price the least-cost system reaches 56% renewables, so the 35% target only binds when gas costs half as much.</a:t>
+              <a:t>At the base gas price the least-cost system reaches 56% renewables, so the 35% target binds only in G-lo-S0, G-lo-S1-15.</a:t>
             </a:r>
           </a:p>
         </p:txBody>
@@ -5255,7 +5255,7 @@
                 </a:solidFill>
                 <a:latin typeface="Calibri"/>
               </a:rPr>
-              <a:t>Demand cut 10-20%, cooling-first saving, shiftable load, gas price x0.5 and x1.5</a:t>
+              <a:t>Demand cut 10%-20%, cooling-first saving, shiftable load, gas price x0.5 and x1.5</a:t>
             </a:r>
           </a:p>
         </p:txBody>
@@ -5423,7 +5423,7 @@
                 </a:solidFill>
                 <a:latin typeface="Calibri"/>
               </a:rPr>
-              <a:t>Every input number has a row and a source in the assumptions register. 93 tests; 98% code coverage; all 11 runs pass the post-solve checks.</a:t>
+              <a:t>Every input number has a row and a source in the assumptions register. All 11 runs pass the post-solve checks.</a:t>
             </a:r>
           </a:p>
         </p:txBody>

</xml_diff>

<commit_message>
feat: run the 2027-2030 pathway and tell it in the docs, report, deck and site
All 11 scenarios now also run year by year from 2027 to 2030, building at
Tunisia's demonstrated pace (268 MW of solar a year, wind from 2029,
batteries from 2029). Renewables reach 22% in 2030 (27% when saving 15%),
so the 35% target is out of reach; each MWh saved over 2027-2030 avoids
70 EUR, 1.95 MWh of gas and 0.39 t of CO2, about twice the gas and CO2 of
the unconstrained 2030 run.

- results: pathway_summary.csv, pathway_avoided.csv, per-year warnings
- figures 10-12: share by year, capacity by year, avoided per year
- docs: Phase 6 write-up, README section, learning path 4-6, glossary
- report section 3.4 and a deck slide; site chapter "To 2030"
- 2030 runs re-run with Voltalia Gabes committed: only "new solar"
  moves (132 MW now counted as committed)
- toy end-to-end pathway test (112 tests, 98% coverage); build_year gains
  calibrate=False for the toy, the real runs are unchanged
</commit_message>
<xml_diff>
--- a/report/deck.pptx
+++ b/report/deck.pptx
@@ -13,6 +13,7 @@
     <p:sldId id="261" r:id="rId13"/>
     <p:sldId id="262" r:id="rId14"/>
     <p:sldId id="263" r:id="rId15"/>
+    <p:sldId id="264" r:id="rId16"/>
   </p:sldIdLst>
   <p:sldSz cx="12191695" cy="6858000" type="screen4x3"/>
   <p:notesSz cx="6858000" cy="9144000"/>
@@ -955,6 +956,76 @@
 </file>
 
 <file path=ppt/notesSlides/notesSlide8.xml><?xml version="1.0" encoding="utf-8"?>
+<p:notes xmlns:a="http://schemas.openxmlformats.org/drawingml/2006/main" xmlns:p="http://schemas.openxmlformats.org/presentationml/2006/main" xmlns:r="http://schemas.openxmlformats.org/officeDocument/2006/relationships">
+  <p:cSld>
+    <p:spTree>
+      <p:nvGrpSpPr>
+        <p:cNvPr id="1" name=""/>
+        <p:cNvGrpSpPr/>
+        <p:nvPr/>
+      </p:nvGrpSpPr>
+      <p:grpSpPr>
+        <a:xfrm>
+          <a:off x="0" y="0"/>
+          <a:ext cx="0" cy="0"/>
+          <a:chOff x="0" y="0"/>
+          <a:chExt cx="0" cy="0"/>
+        </a:xfrm>
+      </p:grpSpPr>
+      <p:sp>
+        <p:nvSpPr>
+          <p:cNvPr id="2" name="Slide Image Placeholder 1"/>
+          <p:cNvSpPr>
+            <a:spLocks noGrp="1"/>
+          </p:cNvSpPr>
+          <p:nvPr>
+            <p:ph type="sldImg" idx="2"/>
+          </p:nvPr>
+        </p:nvSpPr>
+        <p:spPr/>
+      </p:sp>
+      <p:sp>
+        <p:nvSpPr>
+          <p:cNvPr id="3" name="Notes Placeholder 2"/>
+          <p:cNvSpPr>
+            <a:spLocks noGrp="1"/>
+          </p:cNvSpPr>
+          <p:nvPr>
+            <p:ph type="body" idx="3" sz="quarter"/>
+          </p:nvPr>
+        </p:nvSpPr>
+        <p:spPr/>
+        <p:txBody>
+          <a:bodyPr/>
+          <a:lstStyle/>
+          <a:p>
+            <a:r>
+              <a:t>Each year from 2027 starts from the year before; committed projects arrive in their year; new solar is capped at 268 MW a year (Tunisia's best year, 2024), new wind starts in 2029 and batteries in 2029.</a:t>
+            </a:r>
+          </a:p>
+        </p:txBody>
+      </p:sp>
+      <p:sp>
+        <p:nvSpPr>
+          <p:cNvPr id="4" name="Slide Number Placeholder 3"/>
+          <p:cNvSpPr>
+            <a:spLocks noGrp="1"/>
+          </p:cNvSpPr>
+          <p:nvPr>
+            <p:ph type="sldNum" idx="5" sz="quarter"/>
+          </p:nvPr>
+        </p:nvSpPr>
+        <p:spPr/>
+      </p:sp>
+    </p:spTree>
+  </p:cSld>
+  <p:clrMapOvr>
+    <a:masterClrMapping/>
+  </p:clrMapOvr>
+</p:notes>
+</file>
+
+<file path=ppt/notesSlides/notesSlide9.xml><?xml version="1.0" encoding="utf-8"?>
 <p:notes xmlns:a="http://schemas.openxmlformats.org/drawingml/2006/main" xmlns:p="http://schemas.openxmlformats.org/presentationml/2006/main" xmlns:r="http://schemas.openxmlformats.org/officeDocument/2006/relationships">
   <p:cSld>
     <p:spTree>
@@ -6238,6 +6309,289 @@
 <file path=ppt/slides/slide8.xml><?xml version="1.0" encoding="utf-8"?>
 <p:sld xmlns:a="http://schemas.openxmlformats.org/drawingml/2006/main" xmlns:p="http://schemas.openxmlformats.org/presentationml/2006/main" xmlns:r="http://schemas.openxmlformats.org/officeDocument/2006/relationships">
   <p:cSld>
+    <p:spTree>
+      <p:nvGrpSpPr>
+        <p:cNvPr id="1" name=""/>
+        <p:cNvGrpSpPr/>
+        <p:nvPr/>
+      </p:nvGrpSpPr>
+      <p:grpSpPr/>
+      <p:sp>
+        <p:nvSpPr>
+          <p:cNvPr id="2" name="TextBox 1"/>
+          <p:cNvSpPr txBox="1"/>
+          <p:nvPr/>
+        </p:nvSpPr>
+        <p:spPr>
+          <a:xfrm>
+            <a:off x="548640" y="365760"/>
+            <a:ext cx="11064240" cy="914400"/>
+          </a:xfrm>
+          <a:prstGeom prst="rect">
+            <a:avLst/>
+          </a:prstGeom>
+          <a:noFill/>
+        </p:spPr>
+        <p:txBody>
+          <a:bodyPr wrap="square">
+            <a:spAutoFit/>
+          </a:bodyPr>
+          <a:lstStyle/>
+          <a:p>
+            <a:pPr algn="l">
+              <a:spcAft>
+                <a:spcPts val="800"/>
+              </a:spcAft>
+            </a:pPr>
+            <a:r>
+              <a:rPr sz="3200" b="1">
+                <a:solidFill>
+                  <a:srgbClr val="1F1F1F"/>
+                </a:solidFill>
+                <a:latin typeface="Cambria"/>
+              </a:rPr>
+              <a:t>At Tunisia's real pace, 35% is out of reach</a:t>
+            </a:r>
+          </a:p>
+        </p:txBody>
+      </p:sp>
+      <p:pic>
+        <p:nvPicPr>
+          <p:cNvPr id="3" name="Picture 2" descr="10_pathway_res_share.png"/>
+          <p:cNvPicPr>
+            <a:picLocks noChangeAspect="1"/>
+          </p:cNvPicPr>
+          <p:nvPr/>
+        </p:nvPicPr>
+        <p:blipFill>
+          <a:blip r:embed="rId2"/>
+          <a:stretch>
+            <a:fillRect/>
+          </a:stretch>
+        </p:blipFill>
+        <p:spPr>
+          <a:xfrm>
+            <a:off x="365760" y="1371600"/>
+            <a:ext cx="7863840" cy="3774643"/>
+          </a:xfrm>
+          <a:prstGeom prst="rect">
+            <a:avLst/>
+          </a:prstGeom>
+        </p:spPr>
+      </p:pic>
+      <p:sp>
+        <p:nvSpPr>
+          <p:cNvPr id="4" name="Rounded Rectangle 3"/>
+          <p:cNvSpPr/>
+          <p:nvPr/>
+        </p:nvSpPr>
+        <p:spPr>
+          <a:xfrm>
+            <a:off x="8503920" y="1463040"/>
+            <a:ext cx="3200400" cy="4206240"/>
+          </a:xfrm>
+          <a:prstGeom prst="roundRect">
+            <a:avLst>
+              <a:gd name="adj" fmla="val 6000"/>
+            </a:avLst>
+          </a:prstGeom>
+          <a:solidFill>
+            <a:srgbClr val="EEF3F4"/>
+          </a:solidFill>
+          <a:ln>
+            <a:noFill/>
+          </a:ln>
+          <a:effectLst/>
+        </p:spPr>
+        <p:style>
+          <a:lnRef idx="1">
+            <a:schemeClr val="accent1"/>
+          </a:lnRef>
+          <a:fillRef idx="3">
+            <a:schemeClr val="accent1"/>
+          </a:fillRef>
+          <a:effectRef idx="2">
+            <a:schemeClr val="accent1"/>
+          </a:effectRef>
+          <a:fontRef idx="minor">
+            <a:schemeClr val="lt1"/>
+          </a:fontRef>
+        </p:style>
+        <p:txBody>
+          <a:bodyPr rtlCol="0" anchor="ctr"/>
+          <a:lstStyle/>
+          <a:p>
+            <a:pPr algn="ctr"/>
+          </a:p>
+        </p:txBody>
+      </p:sp>
+      <p:sp>
+        <p:nvSpPr>
+          <p:cNvPr id="5" name="TextBox 4"/>
+          <p:cNvSpPr txBox="1"/>
+          <p:nvPr/>
+        </p:nvSpPr>
+        <p:spPr>
+          <a:xfrm>
+            <a:off x="8686800" y="1645920"/>
+            <a:ext cx="2834640" cy="822960"/>
+          </a:xfrm>
+          <a:prstGeom prst="rect">
+            <a:avLst/>
+          </a:prstGeom>
+          <a:noFill/>
+        </p:spPr>
+        <p:txBody>
+          <a:bodyPr wrap="square">
+            <a:spAutoFit/>
+          </a:bodyPr>
+          <a:lstStyle/>
+          <a:p>
+            <a:pPr algn="l">
+              <a:spcAft>
+                <a:spcPts val="800"/>
+              </a:spcAft>
+            </a:pPr>
+            <a:r>
+              <a:rPr sz="3600" b="1">
+                <a:solidFill>
+                  <a:srgbClr val="17323B"/>
+                </a:solidFill>
+                <a:latin typeface="Cambria"/>
+              </a:rPr>
+              <a:t>22%</a:t>
+            </a:r>
+          </a:p>
+        </p:txBody>
+      </p:sp>
+      <p:sp>
+        <p:nvSpPr>
+          <p:cNvPr id="6" name="TextBox 5"/>
+          <p:cNvSpPr txBox="1"/>
+          <p:nvPr/>
+        </p:nvSpPr>
+        <p:spPr>
+          <a:xfrm>
+            <a:off x="8686800" y="2468880"/>
+            <a:ext cx="2834640" cy="822960"/>
+          </a:xfrm>
+          <a:prstGeom prst="rect">
+            <a:avLst/>
+          </a:prstGeom>
+          <a:noFill/>
+        </p:spPr>
+        <p:txBody>
+          <a:bodyPr wrap="square">
+            <a:spAutoFit/>
+          </a:bodyPr>
+          <a:lstStyle/>
+          <a:p>
+            <a:pPr algn="l">
+              <a:spcAft>
+                <a:spcPts val="800"/>
+              </a:spcAft>
+            </a:pPr>
+            <a:r>
+              <a:rPr sz="1400" b="0">
+                <a:solidFill>
+                  <a:srgbClr val="1F1F1F"/>
+                </a:solidFill>
+                <a:latin typeface="Calibri"/>
+              </a:rPr>
+              <a:t>renewables in 2030 without extra saving; 27% when saving 15%</a:t>
+            </a:r>
+          </a:p>
+        </p:txBody>
+      </p:sp>
+      <p:sp>
+        <p:nvSpPr>
+          <p:cNvPr id="7" name="TextBox 6"/>
+          <p:cNvSpPr txBox="1"/>
+          <p:nvPr/>
+        </p:nvSpPr>
+        <p:spPr>
+          <a:xfrm>
+            <a:off x="8686800" y="3566160"/>
+            <a:ext cx="2834640" cy="2011680"/>
+          </a:xfrm>
+          <a:prstGeom prst="rect">
+            <a:avLst/>
+          </a:prstGeom>
+          <a:noFill/>
+        </p:spPr>
+        <p:txBody>
+          <a:bodyPr wrap="square">
+            <a:spAutoFit/>
+          </a:bodyPr>
+          <a:lstStyle/>
+          <a:p>
+            <a:pPr algn="l">
+              <a:spcAft>
+                <a:spcPts val="800"/>
+              </a:spcAft>
+            </a:pPr>
+            <a:r>
+              <a:rPr sz="1500" b="0">
+                <a:solidFill>
+                  <a:srgbClr val="1F1F1F"/>
+                </a:solidFill>
+                <a:latin typeface="Calibri"/>
+              </a:rPr>
+              <a:t>Each MWh saved over 2027-2030 avoids 0.39 t of CO2 and 70 EUR: it comes off a gas plant.</a:t>
+            </a:r>
+          </a:p>
+        </p:txBody>
+      </p:sp>
+      <p:sp>
+        <p:nvSpPr>
+          <p:cNvPr id="8" name="TextBox 7"/>
+          <p:cNvSpPr txBox="1"/>
+          <p:nvPr/>
+        </p:nvSpPr>
+        <p:spPr>
+          <a:xfrm>
+            <a:off x="548640" y="6400800"/>
+            <a:ext cx="11064240" cy="320040"/>
+          </a:xfrm>
+          <a:prstGeom prst="rect">
+            <a:avLst/>
+          </a:prstGeom>
+          <a:noFill/>
+        </p:spPr>
+        <p:txBody>
+          <a:bodyPr wrap="square">
+            <a:spAutoFit/>
+          </a:bodyPr>
+          <a:lstStyle/>
+          <a:p>
+            <a:pPr algn="l">
+              <a:spcAft>
+                <a:spcPts val="800"/>
+              </a:spcAft>
+            </a:pPr>
+            <a:r>
+              <a:rPr sz="1000" b="0">
+                <a:solidFill>
+                  <a:srgbClr val="6B6A66"/>
+                </a:solidFill>
+                <a:latin typeface="Calibri"/>
+              </a:rPr>
+              <a:t>Source: own PyPSA-Earth model of Tunisia 2030; inputs in data/assumptions_register.xlsx</a:t>
+            </a:r>
+          </a:p>
+        </p:txBody>
+      </p:sp>
+    </p:spTree>
+  </p:cSld>
+  <p:clrMapOvr>
+    <a:masterClrMapping/>
+  </p:clrMapOvr>
+</p:sld>
+</file>
+
+<file path=ppt/slides/slide9.xml><?xml version="1.0" encoding="utf-8"?>
+<p:sld xmlns:a="http://schemas.openxmlformats.org/drawingml/2006/main" xmlns:p="http://schemas.openxmlformats.org/presentationml/2006/main" xmlns:r="http://schemas.openxmlformats.org/officeDocument/2006/relationships">
+  <p:cSld>
     <p:bg>
       <p:bgPr>
         <a:solidFill>
@@ -6365,7 +6719,7 @@
                 </a:solidFill>
                 <a:latin typeface="Calibri"/>
               </a:rPr>
-              <a:t>Least cost, not a forecast: no limit on how fast renewables are built</a:t>
+              <a:t>Not a forecast: 2030 alone has no build limit; the pathway's limits are judgements</a:t>
             </a:r>
           </a:p>
           <a:p>
@@ -6507,7 +6861,7 @@
                 </a:solidFill>
                 <a:latin typeface="Calibri"/>
               </a:rPr>
-              <a:t>Cap the yearly renewable build rate with a sourced limit</a:t>
+              <a:t>Test faster build rates as the 2 GW wind tenders progress</a:t>
             </a:r>
           </a:p>
           <a:p>

</xml_diff>